<commit_message>
Update Unidad-5 PPTX: fix agenda index and lab path references
- Agenda now covers all presentation topics in order:
  01: Capabilities & Sniffing de Tráfico
  02: SSRF & Acceso a Cloud Metadata
  03: hostPath Abuse & JWT Token Theft
  04: Herramientas Ofensivas + 4 Labs
- Fix lab path reference in summary slide (u5-labs → Unidad-5)
- Remove script reference that doesn't exist

https://claude.ai/code/session_01AG6rfWQDAAjEPtkmxhGKps
</commit_message>
<xml_diff>
--- a/Unidad-5/Unidad5.pptx
+++ b/Unidad-5/Unidad5.pptx
@@ -14807,7 +14807,7 @@
                 <a:ea typeface="Calibri" pitchFamily="34" charset="-122"/>
                 <a:cs typeface="Calibri" pitchFamily="34" charset="-120"/>
               </a:rPr>
-              <a:t>Archivos disponibles en: u5-labs/lab{1,2,3,4}/ — ejecutar con ./guia-labN.sh</a:t>
+              <a:t>Archivos disponibles en: Unidad-5/lab{1,2,3,4}/</a:t>
             </a:r>
             <a:endParaRPr lang="en-US" sz="950" dirty="0"/>
           </a:p>
@@ -16266,7 +16266,7 @@
                 <a:ea typeface="Trebuchet MS" pitchFamily="34" charset="-122"/>
                 <a:cs typeface="Trebuchet MS" pitchFamily="34" charset="-120"/>
               </a:rPr>
-              <a:t>Acceso a Metadata &amp; SSRF</a:t>
+              <a:t>Capabilities &amp; Sniffing de Tráfico</a:t>
             </a:r>
             <a:endParaRPr lang="en-US" sz="1350" dirty="0"/>
           </a:p>
@@ -16305,7 +16305,7 @@
                 <a:ea typeface="Calibri" pitchFamily="34" charset="-122"/>
                 <a:cs typeface="Calibri" pitchFamily="34" charset="-120"/>
               </a:rPr>
-              <a:t>Cloud IMDS (169.254.169.254), SSRF desde Pods, exfiltración de credenciales</a:t>
+              <a:t>CAP_NET_RAW, interceptación HTTP en texto plano, ARP spoofing entre microservicios</a:t>
             </a:r>
             <a:endParaRPr lang="en-US" sz="950" dirty="0"/>
           </a:p>
@@ -16468,7 +16468,7 @@
                 <a:ea typeface="Trebuchet MS" pitchFamily="34" charset="-122"/>
                 <a:cs typeface="Trebuchet MS" pitchFamily="34" charset="-120"/>
               </a:rPr>
-              <a:t>Abuso del hostPath</a:t>
+              <a:t>SSRF &amp; Acceso a Cloud Metadata</a:t>
             </a:r>
             <a:endParaRPr lang="en-US" sz="1350" dirty="0"/>
           </a:p>
@@ -16507,7 +16507,7 @@
                 <a:ea typeface="Calibri" pitchFamily="34" charset="-122"/>
                 <a:cs typeface="Calibri" pitchFamily="34" charset="-120"/>
               </a:rPr>
-              <a:t>Montaje</a:t>
+              <a:t>Explotación de IMDS (169.254.169.254), robo de credenciales IAM desde Pods</a:t>
             </a:r>
             <a:r>
               <a:rPr lang="en-US" sz="950" dirty="0">
@@ -16518,7 +16518,7 @@
                 <a:ea typeface="Calibri" pitchFamily="34" charset="-122"/>
                 <a:cs typeface="Calibri" pitchFamily="34" charset="-120"/>
               </a:rPr>
-              <a:t> de filesystem del host, lectura de secretos, container escape</a:t>
+              <a:t/>
             </a:r>
             <a:endParaRPr lang="en-US" sz="950" dirty="0"/>
           </a:p>
@@ -16681,7 +16681,7 @@
                 <a:ea typeface="Trebuchet MS" pitchFamily="34" charset="-122"/>
                 <a:cs typeface="Trebuchet MS" pitchFamily="34" charset="-120"/>
               </a:rPr>
-              <a:t>Herramientas Automatizadas</a:t>
+              <a:t>hostPath Abuse &amp; JWT Token Theft</a:t>
             </a:r>
             <a:endParaRPr lang="en-US" sz="1350" dirty="0"/>
           </a:p>
@@ -16720,7 +16720,7 @@
                 <a:ea typeface="Calibri" pitchFamily="34" charset="-122"/>
                 <a:cs typeface="Calibri" pitchFamily="34" charset="-120"/>
               </a:rPr>
-              <a:t>kube-hunter, peirates, kubeaudit, kube-bench, trivy, kubeletctl</a:t>
+              <a:t>Escape al host via volúmenes, robo de tokens JWT y pivoting entre namespaces</a:t>
             </a:r>
             <a:endParaRPr lang="en-US" sz="950" dirty="0"/>
           </a:p>
@@ -16883,7 +16883,7 @@
                 <a:ea typeface="Trebuchet MS" pitchFamily="34" charset="-122"/>
                 <a:cs typeface="Trebuchet MS" pitchFamily="34" charset="-120"/>
               </a:rPr>
-              <a:t>4 Labs Prácticos</a:t>
+              <a:t>Herramientas Ofensivas + 4 Labs</a:t>
             </a:r>
             <a:endParaRPr lang="en-US" sz="1350" dirty="0"/>
           </a:p>
@@ -16922,7 +16922,7 @@
                 <a:ea typeface="Calibri" pitchFamily="34" charset="-122"/>
                 <a:cs typeface="Calibri" pitchFamily="34" charset="-120"/>
               </a:rPr>
-              <a:t>Escenarios de ataque real con explotación y remediación paso a paso</a:t>
+              <a:t>kube-hunter, peirates, trivy + escenarios de ataque con explotación y remediación</a:t>
             </a:r>
             <a:endParaRPr lang="en-US" sz="950" dirty="0"/>
           </a:p>

</xml_diff>